<commit_message>
Update PowerPoint for song #224 in FUBC - Українські
</commit_message>
<xml_diff>
--- a/fubc-ua/224-Я з Христом упевнено крокую (Пісні Спасенних №222).pptx
+++ b/fubc-ua/224-Я з Христом упевнено крокую (Пісні Спасенних №222).pptx
@@ -1607,7 +1607,7 @@
         </p:nvSpPr>
         <p:spPr>
           <a:xfrm>
-            <a:off x="1275817" y="4340352"/>
+            <a:off x="1374877" y="4340352"/>
             <a:ext cx="0" cy="594360"/>
           </a:xfrm>
           <a:prstGeom prst="line">
@@ -1630,7 +1630,7 @@
         </p:nvSpPr>
         <p:spPr>
           <a:xfrm>
-            <a:off x="10922279" y="4340352"/>
+            <a:off x="10823219" y="4340352"/>
             <a:ext cx="0" cy="594360"/>
           </a:xfrm>
           <a:prstGeom prst="line">
@@ -1653,8 +1653,8 @@
         </p:nvSpPr>
         <p:spPr>
           <a:xfrm>
-            <a:off x="11054359" y="4406392"/>
-            <a:ext cx="792480" cy="462280"/>
+            <a:off x="10922279" y="4317492"/>
+            <a:ext cx="1097280" cy="640080"/>
           </a:xfrm>
           <a:prstGeom prst="rect">
             <a:avLst/>
@@ -1670,9 +1670,9 @@
               <a:buNone/>
             </a:pPr>
             <a:r>
-              <a:rPr lang="en-US" sz="2600" b="1" dirty="0">
+              <a:rPr lang="en-US" sz="3600" b="1" dirty="0">
                 <a:solidFill>
-                  <a:srgbClr val="8A8A8A"/>
+                  <a:srgbClr val="BBBBBB"/>
                 </a:solidFill>
                 <a:latin typeface="Arial" pitchFamily="34" charset="0"/>
                 <a:ea typeface="Arial" pitchFamily="34" charset="-122"/>
@@ -1680,7 +1680,7 @@
               </a:rPr>
               <a:t>×2</a:t>
             </a:r>
-            <a:endParaRPr lang="en-US" sz="2600" dirty="0"/>
+            <a:endParaRPr lang="en-US" sz="3600" dirty="0"/>
           </a:p>
         </p:txBody>
       </p:sp>
@@ -1826,7 +1826,7 @@
         </p:nvSpPr>
         <p:spPr>
           <a:xfrm>
-            <a:off x="1702435" y="4340352"/>
+            <a:off x="1801495" y="4340352"/>
             <a:ext cx="0" cy="594360"/>
           </a:xfrm>
           <a:prstGeom prst="line">
@@ -1849,7 +1849,7 @@
         </p:nvSpPr>
         <p:spPr>
           <a:xfrm>
-            <a:off x="10495661" y="4340352"/>
+            <a:off x="10396601" y="4340352"/>
             <a:ext cx="0" cy="594360"/>
           </a:xfrm>
           <a:prstGeom prst="line">
@@ -1872,8 +1872,8 @@
         </p:nvSpPr>
         <p:spPr>
           <a:xfrm>
-            <a:off x="10627741" y="4406392"/>
-            <a:ext cx="792480" cy="462280"/>
+            <a:off x="10495661" y="4317492"/>
+            <a:ext cx="1097280" cy="640080"/>
           </a:xfrm>
           <a:prstGeom prst="rect">
             <a:avLst/>
@@ -1889,9 +1889,9 @@
               <a:buNone/>
             </a:pPr>
             <a:r>
-              <a:rPr lang="en-US" sz="2600" b="1" dirty="0">
+              <a:rPr lang="en-US" sz="3600" b="1" dirty="0">
                 <a:solidFill>
-                  <a:srgbClr val="8A8A8A"/>
+                  <a:srgbClr val="BBBBBB"/>
                 </a:solidFill>
                 <a:latin typeface="Arial" pitchFamily="34" charset="0"/>
                 <a:ea typeface="Arial" pitchFamily="34" charset="-122"/>
@@ -1899,7 +1899,7 @@
               </a:rPr>
               <a:t>×2</a:t>
             </a:r>
-            <a:endParaRPr lang="en-US" sz="2600" dirty="0"/>
+            <a:endParaRPr lang="en-US" sz="3600" dirty="0"/>
           </a:p>
         </p:txBody>
       </p:sp>
@@ -2045,7 +2045,7 @@
         </p:nvSpPr>
         <p:spPr>
           <a:xfrm>
-            <a:off x="1168298" y="4270248"/>
+            <a:off x="1259738" y="4270248"/>
             <a:ext cx="0" cy="548640"/>
           </a:xfrm>
           <a:prstGeom prst="line">
@@ -2068,7 +2068,7 @@
         </p:nvSpPr>
         <p:spPr>
           <a:xfrm>
-            <a:off x="11029798" y="4270248"/>
+            <a:off x="10938358" y="4270248"/>
             <a:ext cx="0" cy="548640"/>
           </a:xfrm>
           <a:prstGeom prst="line">
@@ -2091,8 +2091,8 @@
         </p:nvSpPr>
         <p:spPr>
           <a:xfrm>
-            <a:off x="11151718" y="4331208"/>
-            <a:ext cx="731520" cy="426720"/>
+            <a:off x="11029798" y="4242308"/>
+            <a:ext cx="1036320" cy="604520"/>
           </a:xfrm>
           <a:prstGeom prst="rect">
             <a:avLst/>
@@ -2108,9 +2108,9 @@
               <a:buNone/>
             </a:pPr>
             <a:r>
-              <a:rPr lang="en-US" sz="2400" b="1" dirty="0">
+              <a:rPr lang="en-US" sz="3400" b="1" dirty="0">
                 <a:solidFill>
-                  <a:srgbClr val="8A8A8A"/>
+                  <a:srgbClr val="BBBBBB"/>
                 </a:solidFill>
                 <a:latin typeface="Arial" pitchFamily="34" charset="0"/>
                 <a:ea typeface="Arial" pitchFamily="34" charset="-122"/>
@@ -2118,7 +2118,7 @@
               </a:rPr>
               <a:t>×2</a:t>
             </a:r>
-            <a:endParaRPr lang="en-US" sz="2400" dirty="0"/>
+            <a:endParaRPr lang="en-US" sz="3400" dirty="0"/>
           </a:p>
         </p:txBody>
       </p:sp>
@@ -2177,12 +2177,12 @@
           <a:p>
             <a:pPr algn="ctr" indent="0" marL="0">
               <a:lnSpc>
-                <a:spcPts val="6100"/>
+                <a:spcPts val="6200"/>
               </a:lnSpc>
               <a:buNone/>
             </a:pPr>
             <a:r>
-              <a:rPr lang="en-US" sz="5100" b="1" dirty="0">
+              <a:rPr lang="en-US" sz="5200" b="1" dirty="0">
                 <a:solidFill>
                   <a:srgbClr val="FFFFFF"/>
                 </a:solidFill>
@@ -2192,17 +2192,17 @@
               </a:rPr>
               <a:t>Для життя Господь все посилає,</a:t>
             </a:r>
-            <a:endParaRPr lang="en-US" sz="5100" dirty="0"/>
+            <a:endParaRPr lang="en-US" sz="5200" dirty="0"/>
           </a:p>
           <a:p>
             <a:pPr algn="ctr" indent="0" marL="0">
               <a:lnSpc>
-                <a:spcPts val="6100"/>
+                <a:spcPts val="6200"/>
               </a:lnSpc>
               <a:buNone/>
             </a:pPr>
             <a:r>
-              <a:rPr lang="en-US" sz="5100" b="1" dirty="0">
+              <a:rPr lang="en-US" sz="5200" b="1" dirty="0">
                 <a:solidFill>
                   <a:srgbClr val="FFFFFF"/>
                 </a:solidFill>
@@ -2212,17 +2212,17 @@
               </a:rPr>
               <a:t>знає Він мої потреби всі,</a:t>
             </a:r>
-            <a:endParaRPr lang="en-US" sz="5100" dirty="0"/>
+            <a:endParaRPr lang="en-US" sz="5200" dirty="0"/>
           </a:p>
           <a:p>
             <a:pPr algn="ctr" indent="0" marL="0">
               <a:lnSpc>
-                <a:spcPts val="6100"/>
+                <a:spcPts val="6200"/>
               </a:lnSpc>
               <a:buNone/>
             </a:pPr>
             <a:r>
-              <a:rPr lang="en-US" sz="5100" b="1" dirty="0">
+              <a:rPr lang="en-US" sz="5200" b="1" dirty="0">
                 <a:solidFill>
                   <a:srgbClr val="FFFFFF"/>
                 </a:solidFill>
@@ -2232,17 +2232,17 @@
               </a:rPr>
               <a:t>Словом вічним ніжно утішає,</a:t>
             </a:r>
-            <a:endParaRPr lang="en-US" sz="5100" dirty="0"/>
+            <a:endParaRPr lang="en-US" sz="5200" dirty="0"/>
           </a:p>
           <a:p>
             <a:pPr algn="ctr" indent="0" marL="0">
               <a:lnSpc>
-                <a:spcPts val="6100"/>
+                <a:spcPts val="6200"/>
               </a:lnSpc>
               <a:buNone/>
             </a:pPr>
             <a:r>
-              <a:rPr lang="en-US" sz="5100" b="1" dirty="0">
+              <a:rPr lang="en-US" sz="5200" b="1" dirty="0">
                 <a:solidFill>
                   <a:srgbClr val="FFFFFF"/>
                 </a:solidFill>
@@ -2252,7 +2252,7 @@
               </a:rPr>
               <a:t>скрізь являє Він любов мені.</a:t>
             </a:r>
-            <a:endParaRPr lang="en-US" sz="5100" dirty="0"/>
+            <a:endParaRPr lang="en-US" sz="5200" dirty="0"/>
           </a:p>
         </p:txBody>
       </p:sp>
@@ -2264,14 +2264,14 @@
         </p:nvSpPr>
         <p:spPr>
           <a:xfrm>
-            <a:off x="1069657" y="4322826"/>
-            <a:ext cx="0" cy="582930"/>
+            <a:off x="1070102" y="4340352"/>
+            <a:ext cx="0" cy="594360"/>
           </a:xfrm>
           <a:prstGeom prst="line">
             <a:avLst/>
           </a:prstGeom>
           <a:noFill/>
-          <a:ln w="24912">
+          <a:ln w="25400">
             <a:solidFill>
               <a:srgbClr val="8A8A8A"/>
             </a:solidFill>
@@ -2287,14 +2287,14 @@
         </p:nvSpPr>
         <p:spPr>
           <a:xfrm>
-            <a:off x="11128439" y="4322826"/>
-            <a:ext cx="0" cy="582930"/>
+            <a:off x="11127994" y="4340352"/>
+            <a:ext cx="0" cy="594360"/>
           </a:xfrm>
           <a:prstGeom prst="line">
             <a:avLst/>
           </a:prstGeom>
           <a:noFill/>
-          <a:ln w="24912">
+          <a:ln w="25400">
             <a:solidFill>
               <a:srgbClr val="8A8A8A"/>
             </a:solidFill>
@@ -2310,8 +2310,8 @@
         </p:nvSpPr>
         <p:spPr>
           <a:xfrm>
-            <a:off x="11257979" y="4383151"/>
-            <a:ext cx="792480" cy="462280"/>
+            <a:off x="11227054" y="4317492"/>
+            <a:ext cx="1097280" cy="640080"/>
           </a:xfrm>
           <a:prstGeom prst="rect">
             <a:avLst/>
@@ -2327,9 +2327,9 @@
               <a:buNone/>
             </a:pPr>
             <a:r>
-              <a:rPr lang="en-US" sz="2600" b="1" dirty="0">
+              <a:rPr lang="en-US" sz="3600" b="1" dirty="0">
                 <a:solidFill>
-                  <a:srgbClr val="8A8A8A"/>
+                  <a:srgbClr val="BBBBBB"/>
                 </a:solidFill>
                 <a:latin typeface="Arial" pitchFamily="34" charset="0"/>
                 <a:ea typeface="Arial" pitchFamily="34" charset="-122"/>
@@ -2337,7 +2337,7 @@
               </a:rPr>
               <a:t>×2</a:t>
             </a:r>
-            <a:endParaRPr lang="en-US" sz="2600" dirty="0"/>
+            <a:endParaRPr lang="en-US" sz="3600" dirty="0"/>
           </a:p>
         </p:txBody>
       </p:sp>
@@ -2483,7 +2483,7 @@
         </p:nvSpPr>
         <p:spPr>
           <a:xfrm>
-            <a:off x="1530541" y="4305300"/>
+            <a:off x="1625791" y="4305300"/>
             <a:ext cx="0" cy="571500"/>
           </a:xfrm>
           <a:prstGeom prst="line">
@@ -2506,7 +2506,7 @@
         </p:nvSpPr>
         <p:spPr>
           <a:xfrm>
-            <a:off x="10667555" y="4305300"/>
+            <a:off x="10572306" y="4305300"/>
             <a:ext cx="0" cy="571500"/>
           </a:xfrm>
           <a:prstGeom prst="line">
@@ -2529,8 +2529,8 @@
         </p:nvSpPr>
         <p:spPr>
           <a:xfrm>
-            <a:off x="10794556" y="4368800"/>
-            <a:ext cx="762000" cy="444500"/>
+            <a:off x="10667555" y="4279900"/>
+            <a:ext cx="1066800" cy="622300"/>
           </a:xfrm>
           <a:prstGeom prst="rect">
             <a:avLst/>
@@ -2546,9 +2546,9 @@
               <a:buNone/>
             </a:pPr>
             <a:r>
-              <a:rPr lang="en-US" sz="2500" b="1" dirty="0">
+              <a:rPr lang="en-US" sz="3500" b="1" dirty="0">
                 <a:solidFill>
-                  <a:srgbClr val="8A8A8A"/>
+                  <a:srgbClr val="BBBBBB"/>
                 </a:solidFill>
                 <a:latin typeface="Arial" pitchFamily="34" charset="0"/>
                 <a:ea typeface="Arial" pitchFamily="34" charset="-122"/>
@@ -2556,7 +2556,7 @@
               </a:rPr>
               <a:t>×2</a:t>
             </a:r>
-            <a:endParaRPr lang="en-US" sz="2500" dirty="0"/>
+            <a:endParaRPr lang="en-US" sz="3500" dirty="0"/>
           </a:p>
         </p:txBody>
       </p:sp>

</xml_diff>